<commit_message>
Sửa lỗi, thêm Refresh
</commit_message>
<xml_diff>
--- a/data/templates/target_003.template.pptx
+++ b/data/templates/target_003.template.pptx
@@ -7,7 +7,7 @@
   <p:sldIdLst>
     <p:sldId id="256" r:id="rId2"/>
   </p:sldIdLst>
-  <p:sldSz cx="15124113" cy="10688638"/>
+  <p:sldSz cx="15114588" cy="10688638"/>
   <p:notesSz cx="6858000" cy="9144000"/>
   <p:defaultTextStyle>
     <a:defPPr>
@@ -107,12 +107,12 @@
   <p:extLst>
     <p:ext uri="{EFAFB233-063F-42B5-8137-9DF3F51BA10A}">
       <p15:sldGuideLst xmlns:p15="http://schemas.microsoft.com/office/powerpoint/2012/main">
-        <p15:guide id="1" orient="horz" pos="2160">
+        <p15:guide id="1" orient="horz" pos="2160" userDrawn="1">
           <p15:clr>
             <a:srgbClr val="A4A3A4"/>
           </p15:clr>
         </p15:guide>
-        <p15:guide id="2" pos="2880">
+        <p15:guide id="2" pos="2878" userDrawn="1">
           <p15:clr>
             <a:srgbClr val="A4A3A4"/>
           </p15:clr>
@@ -152,8 +152,8 @@
         </p:nvSpPr>
         <p:spPr>
           <a:xfrm>
-            <a:off x="685800" y="2130425"/>
-            <a:ext cx="7772400" cy="1470025"/>
+            <a:off x="685368" y="2130426"/>
+            <a:ext cx="7767505" cy="1470025"/>
           </a:xfrm>
         </p:spPr>
         <p:txBody>
@@ -179,8 +179,8 @@
         </p:nvSpPr>
         <p:spPr>
           <a:xfrm>
-            <a:off x="1371600" y="3886200"/>
-            <a:ext cx="6400800" cy="1752600"/>
+            <a:off x="1370736" y="3886200"/>
+            <a:ext cx="6396769" cy="1752600"/>
           </a:xfrm>
         </p:spPr>
         <p:txBody>
@@ -196,7 +196,7 @@
                 </a:solidFill>
               </a:defRPr>
             </a:lvl1pPr>
-            <a:lvl2pPr marL="457200" indent="0" algn="ctr">
+            <a:lvl2pPr marL="456926" indent="0" algn="ctr">
               <a:buNone/>
               <a:defRPr>
                 <a:solidFill>
@@ -206,7 +206,7 @@
                 </a:solidFill>
               </a:defRPr>
             </a:lvl2pPr>
-            <a:lvl3pPr marL="914400" indent="0" algn="ctr">
+            <a:lvl3pPr marL="913851" indent="0" algn="ctr">
               <a:buNone/>
               <a:defRPr>
                 <a:solidFill>
@@ -216,7 +216,7 @@
                 </a:solidFill>
               </a:defRPr>
             </a:lvl3pPr>
-            <a:lvl4pPr marL="1371600" indent="0" algn="ctr">
+            <a:lvl4pPr marL="1370777" indent="0" algn="ctr">
               <a:buNone/>
               <a:defRPr>
                 <a:solidFill>
@@ -226,7 +226,7 @@
                 </a:solidFill>
               </a:defRPr>
             </a:lvl4pPr>
-            <a:lvl5pPr marL="1828800" indent="0" algn="ctr">
+            <a:lvl5pPr marL="1827703" indent="0" algn="ctr">
               <a:buNone/>
               <a:defRPr>
                 <a:solidFill>
@@ -236,7 +236,7 @@
                 </a:solidFill>
               </a:defRPr>
             </a:lvl5pPr>
-            <a:lvl6pPr marL="2286000" indent="0" algn="ctr">
+            <a:lvl6pPr marL="2284628" indent="0" algn="ctr">
               <a:buNone/>
               <a:defRPr>
                 <a:solidFill>
@@ -246,7 +246,7 @@
                 </a:solidFill>
               </a:defRPr>
             </a:lvl6pPr>
-            <a:lvl7pPr marL="2743200" indent="0" algn="ctr">
+            <a:lvl7pPr marL="2741554" indent="0" algn="ctr">
               <a:buNone/>
               <a:defRPr>
                 <a:solidFill>
@@ -256,7 +256,7 @@
                 </a:solidFill>
               </a:defRPr>
             </a:lvl7pPr>
-            <a:lvl8pPr marL="3200400" indent="0" algn="ctr">
+            <a:lvl8pPr marL="3198480" indent="0" algn="ctr">
               <a:buNone/>
               <a:defRPr>
                 <a:solidFill>
@@ -266,7 +266,7 @@
                 </a:solidFill>
               </a:defRPr>
             </a:lvl8pPr>
-            <a:lvl9pPr marL="3657600" indent="0" algn="ctr">
+            <a:lvl9pPr marL="3655405" indent="0" algn="ctr">
               <a:buNone/>
               <a:defRPr>
                 <a:solidFill>
@@ -302,7 +302,7 @@
           <a:p>
             <a:fld id="{5BCAD085-E8A6-8845-BD4E-CB4CCA059FC4}" type="datetimeFigureOut">
               <a:rPr lang="en-US" smtClean="0"/>
-              <a:t>7/9/2026</a:t>
+              <a:t>7/11/2026</a:t>
             </a:fld>
             <a:endParaRPr lang="en-US"/>
           </a:p>
@@ -470,7 +470,7 @@
           <a:p>
             <a:fld id="{5BCAD085-E8A6-8845-BD4E-CB4CCA059FC4}" type="datetimeFigureOut">
               <a:rPr lang="en-US" smtClean="0"/>
-              <a:t>7/9/2026</a:t>
+              <a:t>7/11/2026</a:t>
             </a:fld>
             <a:endParaRPr lang="en-US"/>
           </a:p>
@@ -560,8 +560,8 @@
         </p:nvSpPr>
         <p:spPr>
           <a:xfrm>
-            <a:off x="6629400" y="274638"/>
-            <a:ext cx="2057400" cy="5851525"/>
+            <a:off x="6625225" y="274639"/>
+            <a:ext cx="2056104" cy="5851525"/>
           </a:xfrm>
         </p:spPr>
         <p:txBody>
@@ -587,8 +587,8 @@
         </p:nvSpPr>
         <p:spPr>
           <a:xfrm>
-            <a:off x="457200" y="274638"/>
-            <a:ext cx="6019800" cy="5851525"/>
+            <a:off x="456912" y="274639"/>
+            <a:ext cx="6016009" cy="5851525"/>
           </a:xfrm>
         </p:spPr>
         <p:txBody>
@@ -648,7 +648,7 @@
           <a:p>
             <a:fld id="{5BCAD085-E8A6-8845-BD4E-CB4CCA059FC4}" type="datetimeFigureOut">
               <a:rPr lang="en-US" smtClean="0"/>
-              <a:t>7/9/2026</a:t>
+              <a:t>7/11/2026</a:t>
             </a:fld>
             <a:endParaRPr lang="en-US"/>
           </a:p>
@@ -816,7 +816,7 @@
           <a:p>
             <a:fld id="{5BCAD085-E8A6-8845-BD4E-CB4CCA059FC4}" type="datetimeFigureOut">
               <a:rPr lang="en-US" smtClean="0"/>
-              <a:t>7/9/2026</a:t>
+              <a:t>7/11/2026</a:t>
             </a:fld>
             <a:endParaRPr lang="en-US"/>
           </a:p>
@@ -906,15 +906,15 @@
         </p:nvSpPr>
         <p:spPr>
           <a:xfrm>
-            <a:off x="722313" y="4406900"/>
-            <a:ext cx="7772400" cy="1362075"/>
+            <a:off x="721858" y="4406901"/>
+            <a:ext cx="7767505" cy="1362075"/>
           </a:xfrm>
         </p:spPr>
         <p:txBody>
           <a:bodyPr anchor="t"/>
           <a:lstStyle>
             <a:lvl1pPr algn="l">
-              <a:defRPr sz="4000" b="1" cap="all"/>
+              <a:defRPr sz="3998" b="1" cap="all"/>
             </a:lvl1pPr>
           </a:lstStyle>
           <a:p>
@@ -937,8 +937,8 @@
         </p:nvSpPr>
         <p:spPr>
           <a:xfrm>
-            <a:off x="722313" y="2906713"/>
-            <a:ext cx="7772400" cy="1500187"/>
+            <a:off x="721858" y="2906714"/>
+            <a:ext cx="7767505" cy="1500187"/>
           </a:xfrm>
         </p:spPr>
         <p:txBody>
@@ -946,7 +946,7 @@
           <a:lstStyle>
             <a:lvl1pPr marL="0" indent="0">
               <a:buNone/>
-              <a:defRPr sz="2000">
+              <a:defRPr sz="1999">
                 <a:solidFill>
                   <a:schemeClr val="tx1">
                     <a:tint val="75000"/>
@@ -954,9 +954,9 @@
                 </a:solidFill>
               </a:defRPr>
             </a:lvl1pPr>
-            <a:lvl2pPr marL="457200" indent="0">
-              <a:buNone/>
-              <a:defRPr sz="1800">
+            <a:lvl2pPr marL="456926" indent="0">
+              <a:buNone/>
+              <a:defRPr sz="1799">
                 <a:solidFill>
                   <a:schemeClr val="tx1">
                     <a:tint val="75000"/>
@@ -964,9 +964,9 @@
                 </a:solidFill>
               </a:defRPr>
             </a:lvl2pPr>
-            <a:lvl3pPr marL="914400" indent="0">
-              <a:buNone/>
-              <a:defRPr sz="1600">
+            <a:lvl3pPr marL="913851" indent="0">
+              <a:buNone/>
+              <a:defRPr sz="1599">
                 <a:solidFill>
                   <a:schemeClr val="tx1">
                     <a:tint val="75000"/>
@@ -974,9 +974,9 @@
                 </a:solidFill>
               </a:defRPr>
             </a:lvl3pPr>
-            <a:lvl4pPr marL="1371600" indent="0">
-              <a:buNone/>
-              <a:defRPr sz="1400">
+            <a:lvl4pPr marL="1370777" indent="0">
+              <a:buNone/>
+              <a:defRPr sz="1399">
                 <a:solidFill>
                   <a:schemeClr val="tx1">
                     <a:tint val="75000"/>
@@ -984,9 +984,9 @@
                 </a:solidFill>
               </a:defRPr>
             </a:lvl4pPr>
-            <a:lvl5pPr marL="1828800" indent="0">
-              <a:buNone/>
-              <a:defRPr sz="1400">
+            <a:lvl5pPr marL="1827703" indent="0">
+              <a:buNone/>
+              <a:defRPr sz="1399">
                 <a:solidFill>
                   <a:schemeClr val="tx1">
                     <a:tint val="75000"/>
@@ -994,9 +994,9 @@
                 </a:solidFill>
               </a:defRPr>
             </a:lvl5pPr>
-            <a:lvl6pPr marL="2286000" indent="0">
-              <a:buNone/>
-              <a:defRPr sz="1400">
+            <a:lvl6pPr marL="2284628" indent="0">
+              <a:buNone/>
+              <a:defRPr sz="1399">
                 <a:solidFill>
                   <a:schemeClr val="tx1">
                     <a:tint val="75000"/>
@@ -1004,9 +1004,9 @@
                 </a:solidFill>
               </a:defRPr>
             </a:lvl6pPr>
-            <a:lvl7pPr marL="2743200" indent="0">
-              <a:buNone/>
-              <a:defRPr sz="1400">
+            <a:lvl7pPr marL="2741554" indent="0">
+              <a:buNone/>
+              <a:defRPr sz="1399">
                 <a:solidFill>
                   <a:schemeClr val="tx1">
                     <a:tint val="75000"/>
@@ -1014,9 +1014,9 @@
                 </a:solidFill>
               </a:defRPr>
             </a:lvl7pPr>
-            <a:lvl8pPr marL="3200400" indent="0">
-              <a:buNone/>
-              <a:defRPr sz="1400">
+            <a:lvl8pPr marL="3198480" indent="0">
+              <a:buNone/>
+              <a:defRPr sz="1399">
                 <a:solidFill>
                   <a:schemeClr val="tx1">
                     <a:tint val="75000"/>
@@ -1024,9 +1024,9 @@
                 </a:solidFill>
               </a:defRPr>
             </a:lvl8pPr>
-            <a:lvl9pPr marL="3657600" indent="0">
-              <a:buNone/>
-              <a:defRPr sz="1400">
+            <a:lvl9pPr marL="3655405" indent="0">
+              <a:buNone/>
+              <a:defRPr sz="1399">
                 <a:solidFill>
                   <a:schemeClr val="tx1">
                     <a:tint val="75000"/>
@@ -1061,7 +1061,7 @@
           <a:p>
             <a:fld id="{5BCAD085-E8A6-8845-BD4E-CB4CCA059FC4}" type="datetimeFigureOut">
               <a:rPr lang="en-US" smtClean="0"/>
-              <a:t>7/9/2026</a:t>
+              <a:t>7/11/2026</a:t>
             </a:fld>
             <a:endParaRPr lang="en-US"/>
           </a:p>
@@ -1173,39 +1173,39 @@
         </p:nvSpPr>
         <p:spPr>
           <a:xfrm>
-            <a:off x="457200" y="1600200"/>
-            <a:ext cx="4038600" cy="4525963"/>
+            <a:off x="456912" y="1600201"/>
+            <a:ext cx="4036057" cy="4525963"/>
           </a:xfrm>
         </p:spPr>
         <p:txBody>
           <a:bodyPr/>
           <a:lstStyle>
             <a:lvl1pPr>
-              <a:defRPr sz="2800"/>
+              <a:defRPr sz="2798"/>
             </a:lvl1pPr>
             <a:lvl2pPr>
-              <a:defRPr sz="2400"/>
+              <a:defRPr sz="2399"/>
             </a:lvl2pPr>
             <a:lvl3pPr>
-              <a:defRPr sz="2000"/>
+              <a:defRPr sz="1999"/>
             </a:lvl3pPr>
             <a:lvl4pPr>
-              <a:defRPr sz="1800"/>
+              <a:defRPr sz="1799"/>
             </a:lvl4pPr>
             <a:lvl5pPr>
-              <a:defRPr sz="1800"/>
+              <a:defRPr sz="1799"/>
             </a:lvl5pPr>
             <a:lvl6pPr>
-              <a:defRPr sz="1800"/>
+              <a:defRPr sz="1799"/>
             </a:lvl6pPr>
             <a:lvl7pPr>
-              <a:defRPr sz="1800"/>
+              <a:defRPr sz="1799"/>
             </a:lvl7pPr>
             <a:lvl8pPr>
-              <a:defRPr sz="1800"/>
+              <a:defRPr sz="1799"/>
             </a:lvl8pPr>
             <a:lvl9pPr>
-              <a:defRPr sz="1800"/>
+              <a:defRPr sz="1799"/>
             </a:lvl9pPr>
           </a:lstStyle>
           <a:p>
@@ -1257,39 +1257,39 @@
         </p:nvSpPr>
         <p:spPr>
           <a:xfrm>
-            <a:off x="4648200" y="1600200"/>
-            <a:ext cx="4038600" cy="4525963"/>
+            <a:off x="4645272" y="1600201"/>
+            <a:ext cx="4036057" cy="4525963"/>
           </a:xfrm>
         </p:spPr>
         <p:txBody>
           <a:bodyPr/>
           <a:lstStyle>
             <a:lvl1pPr>
-              <a:defRPr sz="2800"/>
+              <a:defRPr sz="2798"/>
             </a:lvl1pPr>
             <a:lvl2pPr>
-              <a:defRPr sz="2400"/>
+              <a:defRPr sz="2399"/>
             </a:lvl2pPr>
             <a:lvl3pPr>
-              <a:defRPr sz="2000"/>
+              <a:defRPr sz="1999"/>
             </a:lvl3pPr>
             <a:lvl4pPr>
-              <a:defRPr sz="1800"/>
+              <a:defRPr sz="1799"/>
             </a:lvl4pPr>
             <a:lvl5pPr>
-              <a:defRPr sz="1800"/>
+              <a:defRPr sz="1799"/>
             </a:lvl5pPr>
             <a:lvl6pPr>
-              <a:defRPr sz="1800"/>
+              <a:defRPr sz="1799"/>
             </a:lvl6pPr>
             <a:lvl7pPr>
-              <a:defRPr sz="1800"/>
+              <a:defRPr sz="1799"/>
             </a:lvl7pPr>
             <a:lvl8pPr>
-              <a:defRPr sz="1800"/>
+              <a:defRPr sz="1799"/>
             </a:lvl8pPr>
             <a:lvl9pPr>
-              <a:defRPr sz="1800"/>
+              <a:defRPr sz="1799"/>
             </a:lvl9pPr>
           </a:lstStyle>
           <a:p>
@@ -1346,7 +1346,7 @@
           <a:p>
             <a:fld id="{5BCAD085-E8A6-8845-BD4E-CB4CCA059FC4}" type="datetimeFigureOut">
               <a:rPr lang="en-US" smtClean="0"/>
-              <a:t>7/9/2026</a:t>
+              <a:t>7/11/2026</a:t>
             </a:fld>
             <a:endParaRPr lang="en-US"/>
           </a:p>
@@ -1462,8 +1462,8 @@
         </p:nvSpPr>
         <p:spPr>
           <a:xfrm>
-            <a:off x="457200" y="1535113"/>
-            <a:ext cx="4040188" cy="639762"/>
+            <a:off x="456912" y="1535113"/>
+            <a:ext cx="4037644" cy="639762"/>
           </a:xfrm>
         </p:spPr>
         <p:txBody>
@@ -1471,39 +1471,39 @@
           <a:lstStyle>
             <a:lvl1pPr marL="0" indent="0">
               <a:buNone/>
-              <a:defRPr sz="2400" b="1"/>
+              <a:defRPr sz="2399" b="1"/>
             </a:lvl1pPr>
-            <a:lvl2pPr marL="457200" indent="0">
-              <a:buNone/>
-              <a:defRPr sz="2000" b="1"/>
+            <a:lvl2pPr marL="456926" indent="0">
+              <a:buNone/>
+              <a:defRPr sz="1999" b="1"/>
             </a:lvl2pPr>
-            <a:lvl3pPr marL="914400" indent="0">
-              <a:buNone/>
-              <a:defRPr sz="1800" b="1"/>
+            <a:lvl3pPr marL="913851" indent="0">
+              <a:buNone/>
+              <a:defRPr sz="1799" b="1"/>
             </a:lvl3pPr>
-            <a:lvl4pPr marL="1371600" indent="0">
-              <a:buNone/>
-              <a:defRPr sz="1600" b="1"/>
+            <a:lvl4pPr marL="1370777" indent="0">
+              <a:buNone/>
+              <a:defRPr sz="1599" b="1"/>
             </a:lvl4pPr>
-            <a:lvl5pPr marL="1828800" indent="0">
-              <a:buNone/>
-              <a:defRPr sz="1600" b="1"/>
+            <a:lvl5pPr marL="1827703" indent="0">
+              <a:buNone/>
+              <a:defRPr sz="1599" b="1"/>
             </a:lvl5pPr>
-            <a:lvl6pPr marL="2286000" indent="0">
-              <a:buNone/>
-              <a:defRPr sz="1600" b="1"/>
+            <a:lvl6pPr marL="2284628" indent="0">
+              <a:buNone/>
+              <a:defRPr sz="1599" b="1"/>
             </a:lvl6pPr>
-            <a:lvl7pPr marL="2743200" indent="0">
-              <a:buNone/>
-              <a:defRPr sz="1600" b="1"/>
+            <a:lvl7pPr marL="2741554" indent="0">
+              <a:buNone/>
+              <a:defRPr sz="1599" b="1"/>
             </a:lvl7pPr>
-            <a:lvl8pPr marL="3200400" indent="0">
-              <a:buNone/>
-              <a:defRPr sz="1600" b="1"/>
+            <a:lvl8pPr marL="3198480" indent="0">
+              <a:buNone/>
+              <a:defRPr sz="1599" b="1"/>
             </a:lvl8pPr>
-            <a:lvl9pPr marL="3657600" indent="0">
-              <a:buNone/>
-              <a:defRPr sz="1600" b="1"/>
+            <a:lvl9pPr marL="3655405" indent="0">
+              <a:buNone/>
+              <a:defRPr sz="1599" b="1"/>
             </a:lvl9pPr>
           </a:lstStyle>
           <a:p>
@@ -1527,39 +1527,39 @@
         </p:nvSpPr>
         <p:spPr>
           <a:xfrm>
-            <a:off x="457200" y="2174875"/>
-            <a:ext cx="4040188" cy="3951288"/>
+            <a:off x="456912" y="2174875"/>
+            <a:ext cx="4037644" cy="3951288"/>
           </a:xfrm>
         </p:spPr>
         <p:txBody>
           <a:bodyPr/>
           <a:lstStyle>
             <a:lvl1pPr>
-              <a:defRPr sz="2400"/>
+              <a:defRPr sz="2399"/>
             </a:lvl1pPr>
             <a:lvl2pPr>
-              <a:defRPr sz="2000"/>
+              <a:defRPr sz="1999"/>
             </a:lvl2pPr>
             <a:lvl3pPr>
-              <a:defRPr sz="1800"/>
+              <a:defRPr sz="1799"/>
             </a:lvl3pPr>
             <a:lvl4pPr>
-              <a:defRPr sz="1600"/>
+              <a:defRPr sz="1599"/>
             </a:lvl4pPr>
             <a:lvl5pPr>
-              <a:defRPr sz="1600"/>
+              <a:defRPr sz="1599"/>
             </a:lvl5pPr>
             <a:lvl6pPr>
-              <a:defRPr sz="1600"/>
+              <a:defRPr sz="1599"/>
             </a:lvl6pPr>
             <a:lvl7pPr>
-              <a:defRPr sz="1600"/>
+              <a:defRPr sz="1599"/>
             </a:lvl7pPr>
             <a:lvl8pPr>
-              <a:defRPr sz="1600"/>
+              <a:defRPr sz="1599"/>
             </a:lvl8pPr>
             <a:lvl9pPr>
-              <a:defRPr sz="1600"/>
+              <a:defRPr sz="1599"/>
             </a:lvl9pPr>
           </a:lstStyle>
           <a:p>
@@ -1611,8 +1611,8 @@
         </p:nvSpPr>
         <p:spPr>
           <a:xfrm>
-            <a:off x="4645025" y="1535113"/>
-            <a:ext cx="4041775" cy="639762"/>
+            <a:off x="4642100" y="1535113"/>
+            <a:ext cx="4039230" cy="639762"/>
           </a:xfrm>
         </p:spPr>
         <p:txBody>
@@ -1620,39 +1620,39 @@
           <a:lstStyle>
             <a:lvl1pPr marL="0" indent="0">
               <a:buNone/>
-              <a:defRPr sz="2400" b="1"/>
+              <a:defRPr sz="2399" b="1"/>
             </a:lvl1pPr>
-            <a:lvl2pPr marL="457200" indent="0">
-              <a:buNone/>
-              <a:defRPr sz="2000" b="1"/>
+            <a:lvl2pPr marL="456926" indent="0">
+              <a:buNone/>
+              <a:defRPr sz="1999" b="1"/>
             </a:lvl2pPr>
-            <a:lvl3pPr marL="914400" indent="0">
-              <a:buNone/>
-              <a:defRPr sz="1800" b="1"/>
+            <a:lvl3pPr marL="913851" indent="0">
+              <a:buNone/>
+              <a:defRPr sz="1799" b="1"/>
             </a:lvl3pPr>
-            <a:lvl4pPr marL="1371600" indent="0">
-              <a:buNone/>
-              <a:defRPr sz="1600" b="1"/>
+            <a:lvl4pPr marL="1370777" indent="0">
+              <a:buNone/>
+              <a:defRPr sz="1599" b="1"/>
             </a:lvl4pPr>
-            <a:lvl5pPr marL="1828800" indent="0">
-              <a:buNone/>
-              <a:defRPr sz="1600" b="1"/>
+            <a:lvl5pPr marL="1827703" indent="0">
+              <a:buNone/>
+              <a:defRPr sz="1599" b="1"/>
             </a:lvl5pPr>
-            <a:lvl6pPr marL="2286000" indent="0">
-              <a:buNone/>
-              <a:defRPr sz="1600" b="1"/>
+            <a:lvl6pPr marL="2284628" indent="0">
+              <a:buNone/>
+              <a:defRPr sz="1599" b="1"/>
             </a:lvl6pPr>
-            <a:lvl7pPr marL="2743200" indent="0">
-              <a:buNone/>
-              <a:defRPr sz="1600" b="1"/>
+            <a:lvl7pPr marL="2741554" indent="0">
+              <a:buNone/>
+              <a:defRPr sz="1599" b="1"/>
             </a:lvl7pPr>
-            <a:lvl8pPr marL="3200400" indent="0">
-              <a:buNone/>
-              <a:defRPr sz="1600" b="1"/>
+            <a:lvl8pPr marL="3198480" indent="0">
+              <a:buNone/>
+              <a:defRPr sz="1599" b="1"/>
             </a:lvl8pPr>
-            <a:lvl9pPr marL="3657600" indent="0">
-              <a:buNone/>
-              <a:defRPr sz="1600" b="1"/>
+            <a:lvl9pPr marL="3655405" indent="0">
+              <a:buNone/>
+              <a:defRPr sz="1599" b="1"/>
             </a:lvl9pPr>
           </a:lstStyle>
           <a:p>
@@ -1676,39 +1676,39 @@
         </p:nvSpPr>
         <p:spPr>
           <a:xfrm>
-            <a:off x="4645025" y="2174875"/>
-            <a:ext cx="4041775" cy="3951288"/>
+            <a:off x="4642100" y="2174875"/>
+            <a:ext cx="4039230" cy="3951288"/>
           </a:xfrm>
         </p:spPr>
         <p:txBody>
           <a:bodyPr/>
           <a:lstStyle>
             <a:lvl1pPr>
-              <a:defRPr sz="2400"/>
+              <a:defRPr sz="2399"/>
             </a:lvl1pPr>
             <a:lvl2pPr>
-              <a:defRPr sz="2000"/>
+              <a:defRPr sz="1999"/>
             </a:lvl2pPr>
             <a:lvl3pPr>
-              <a:defRPr sz="1800"/>
+              <a:defRPr sz="1799"/>
             </a:lvl3pPr>
             <a:lvl4pPr>
-              <a:defRPr sz="1600"/>
+              <a:defRPr sz="1599"/>
             </a:lvl4pPr>
             <a:lvl5pPr>
-              <a:defRPr sz="1600"/>
+              <a:defRPr sz="1599"/>
             </a:lvl5pPr>
             <a:lvl6pPr>
-              <a:defRPr sz="1600"/>
+              <a:defRPr sz="1599"/>
             </a:lvl6pPr>
             <a:lvl7pPr>
-              <a:defRPr sz="1600"/>
+              <a:defRPr sz="1599"/>
             </a:lvl7pPr>
             <a:lvl8pPr>
-              <a:defRPr sz="1600"/>
+              <a:defRPr sz="1599"/>
             </a:lvl8pPr>
             <a:lvl9pPr>
-              <a:defRPr sz="1600"/>
+              <a:defRPr sz="1599"/>
             </a:lvl9pPr>
           </a:lstStyle>
           <a:p>
@@ -1765,7 +1765,7 @@
           <a:p>
             <a:fld id="{5BCAD085-E8A6-8845-BD4E-CB4CCA059FC4}" type="datetimeFigureOut">
               <a:rPr lang="en-US" smtClean="0"/>
-              <a:t>7/9/2026</a:t>
+              <a:t>7/11/2026</a:t>
             </a:fld>
             <a:endParaRPr lang="en-US"/>
           </a:p>
@@ -1882,7 +1882,7 @@
           <a:p>
             <a:fld id="{5BCAD085-E8A6-8845-BD4E-CB4CCA059FC4}" type="datetimeFigureOut">
               <a:rPr lang="en-US" smtClean="0"/>
-              <a:t>7/9/2026</a:t>
+              <a:t>7/11/2026</a:t>
             </a:fld>
             <a:endParaRPr lang="en-US"/>
           </a:p>
@@ -1977,7 +1977,7 @@
           <a:p>
             <a:fld id="{5BCAD085-E8A6-8845-BD4E-CB4CCA059FC4}" type="datetimeFigureOut">
               <a:rPr lang="en-US" smtClean="0"/>
-              <a:t>7/9/2026</a:t>
+              <a:t>7/11/2026</a:t>
             </a:fld>
             <a:endParaRPr lang="en-US"/>
           </a:p>
@@ -2067,15 +2067,15 @@
         </p:nvSpPr>
         <p:spPr>
           <a:xfrm>
-            <a:off x="457200" y="273050"/>
-            <a:ext cx="3008313" cy="1162050"/>
+            <a:off x="456913" y="273050"/>
+            <a:ext cx="3006418" cy="1162050"/>
           </a:xfrm>
         </p:spPr>
         <p:txBody>
           <a:bodyPr anchor="b"/>
           <a:lstStyle>
             <a:lvl1pPr algn="l">
-              <a:defRPr sz="2000" b="1"/>
+              <a:defRPr sz="1999" b="1"/>
             </a:lvl1pPr>
           </a:lstStyle>
           <a:p>
@@ -2098,39 +2098,39 @@
         </p:nvSpPr>
         <p:spPr>
           <a:xfrm>
-            <a:off x="3575050" y="273050"/>
-            <a:ext cx="5111750" cy="5853113"/>
+            <a:off x="3572798" y="273051"/>
+            <a:ext cx="5108531" cy="5853113"/>
           </a:xfrm>
         </p:spPr>
         <p:txBody>
           <a:bodyPr/>
           <a:lstStyle>
             <a:lvl1pPr>
-              <a:defRPr sz="3200"/>
+              <a:defRPr sz="3198"/>
             </a:lvl1pPr>
             <a:lvl2pPr>
-              <a:defRPr sz="2800"/>
+              <a:defRPr sz="2798"/>
             </a:lvl2pPr>
             <a:lvl3pPr>
-              <a:defRPr sz="2400"/>
+              <a:defRPr sz="2399"/>
             </a:lvl3pPr>
             <a:lvl4pPr>
-              <a:defRPr sz="2000"/>
+              <a:defRPr sz="1999"/>
             </a:lvl4pPr>
             <a:lvl5pPr>
-              <a:defRPr sz="2000"/>
+              <a:defRPr sz="1999"/>
             </a:lvl5pPr>
             <a:lvl6pPr>
-              <a:defRPr sz="2000"/>
+              <a:defRPr sz="1999"/>
             </a:lvl6pPr>
             <a:lvl7pPr>
-              <a:defRPr sz="2000"/>
+              <a:defRPr sz="1999"/>
             </a:lvl7pPr>
             <a:lvl8pPr>
-              <a:defRPr sz="2000"/>
+              <a:defRPr sz="1999"/>
             </a:lvl8pPr>
             <a:lvl9pPr>
-              <a:defRPr sz="2000"/>
+              <a:defRPr sz="1999"/>
             </a:lvl9pPr>
           </a:lstStyle>
           <a:p>
@@ -2182,8 +2182,8 @@
         </p:nvSpPr>
         <p:spPr>
           <a:xfrm>
-            <a:off x="457200" y="1435100"/>
-            <a:ext cx="3008313" cy="4691063"/>
+            <a:off x="456913" y="1435101"/>
+            <a:ext cx="3006418" cy="4691063"/>
           </a:xfrm>
         </p:spPr>
         <p:txBody>
@@ -2191,39 +2191,39 @@
           <a:lstStyle>
             <a:lvl1pPr marL="0" indent="0">
               <a:buNone/>
-              <a:defRPr sz="1400"/>
+              <a:defRPr sz="1399"/>
             </a:lvl1pPr>
-            <a:lvl2pPr marL="457200" indent="0">
-              <a:buNone/>
-              <a:defRPr sz="1200"/>
+            <a:lvl2pPr marL="456926" indent="0">
+              <a:buNone/>
+              <a:defRPr sz="1199"/>
             </a:lvl2pPr>
-            <a:lvl3pPr marL="914400" indent="0">
-              <a:buNone/>
-              <a:defRPr sz="1000"/>
+            <a:lvl3pPr marL="913851" indent="0">
+              <a:buNone/>
+              <a:defRPr sz="999"/>
             </a:lvl3pPr>
-            <a:lvl4pPr marL="1371600" indent="0">
-              <a:buNone/>
-              <a:defRPr sz="900"/>
+            <a:lvl4pPr marL="1370777" indent="0">
+              <a:buNone/>
+              <a:defRPr sz="899"/>
             </a:lvl4pPr>
-            <a:lvl5pPr marL="1828800" indent="0">
-              <a:buNone/>
-              <a:defRPr sz="900"/>
+            <a:lvl5pPr marL="1827703" indent="0">
+              <a:buNone/>
+              <a:defRPr sz="899"/>
             </a:lvl5pPr>
-            <a:lvl6pPr marL="2286000" indent="0">
-              <a:buNone/>
-              <a:defRPr sz="900"/>
+            <a:lvl6pPr marL="2284628" indent="0">
+              <a:buNone/>
+              <a:defRPr sz="899"/>
             </a:lvl6pPr>
-            <a:lvl7pPr marL="2743200" indent="0">
-              <a:buNone/>
-              <a:defRPr sz="900"/>
+            <a:lvl7pPr marL="2741554" indent="0">
+              <a:buNone/>
+              <a:defRPr sz="899"/>
             </a:lvl7pPr>
-            <a:lvl8pPr marL="3200400" indent="0">
-              <a:buNone/>
-              <a:defRPr sz="900"/>
+            <a:lvl8pPr marL="3198480" indent="0">
+              <a:buNone/>
+              <a:defRPr sz="899"/>
             </a:lvl8pPr>
-            <a:lvl9pPr marL="3657600" indent="0">
-              <a:buNone/>
-              <a:defRPr sz="900"/>
+            <a:lvl9pPr marL="3655405" indent="0">
+              <a:buNone/>
+              <a:defRPr sz="899"/>
             </a:lvl9pPr>
           </a:lstStyle>
           <a:p>
@@ -2252,7 +2252,7 @@
           <a:p>
             <a:fld id="{5BCAD085-E8A6-8845-BD4E-CB4CCA059FC4}" type="datetimeFigureOut">
               <a:rPr lang="en-US" smtClean="0"/>
-              <a:t>7/9/2026</a:t>
+              <a:t>7/11/2026</a:t>
             </a:fld>
             <a:endParaRPr lang="en-US"/>
           </a:p>
@@ -2342,15 +2342,15 @@
         </p:nvSpPr>
         <p:spPr>
           <a:xfrm>
-            <a:off x="1792288" y="4800600"/>
-            <a:ext cx="5486400" cy="566738"/>
+            <a:off x="1791159" y="4800600"/>
+            <a:ext cx="5482945" cy="566738"/>
           </a:xfrm>
         </p:spPr>
         <p:txBody>
           <a:bodyPr anchor="b"/>
           <a:lstStyle>
             <a:lvl1pPr algn="l">
-              <a:defRPr sz="2000" b="1"/>
+              <a:defRPr sz="1999" b="1"/>
             </a:lvl1pPr>
           </a:lstStyle>
           <a:p>
@@ -2373,8 +2373,8 @@
         </p:nvSpPr>
         <p:spPr>
           <a:xfrm>
-            <a:off x="1792288" y="612775"/>
-            <a:ext cx="5486400" cy="4114800"/>
+            <a:off x="1791159" y="612775"/>
+            <a:ext cx="5482945" cy="4114800"/>
           </a:xfrm>
         </p:spPr>
         <p:txBody>
@@ -2382,39 +2382,39 @@
           <a:lstStyle>
             <a:lvl1pPr marL="0" indent="0">
               <a:buNone/>
-              <a:defRPr sz="3200"/>
+              <a:defRPr sz="3198"/>
             </a:lvl1pPr>
-            <a:lvl2pPr marL="457200" indent="0">
-              <a:buNone/>
-              <a:defRPr sz="2800"/>
+            <a:lvl2pPr marL="456926" indent="0">
+              <a:buNone/>
+              <a:defRPr sz="2798"/>
             </a:lvl2pPr>
-            <a:lvl3pPr marL="914400" indent="0">
-              <a:buNone/>
-              <a:defRPr sz="2400"/>
+            <a:lvl3pPr marL="913851" indent="0">
+              <a:buNone/>
+              <a:defRPr sz="2399"/>
             </a:lvl3pPr>
-            <a:lvl4pPr marL="1371600" indent="0">
-              <a:buNone/>
-              <a:defRPr sz="2000"/>
+            <a:lvl4pPr marL="1370777" indent="0">
+              <a:buNone/>
+              <a:defRPr sz="1999"/>
             </a:lvl4pPr>
-            <a:lvl5pPr marL="1828800" indent="0">
-              <a:buNone/>
-              <a:defRPr sz="2000"/>
+            <a:lvl5pPr marL="1827703" indent="0">
+              <a:buNone/>
+              <a:defRPr sz="1999"/>
             </a:lvl5pPr>
-            <a:lvl6pPr marL="2286000" indent="0">
-              <a:buNone/>
-              <a:defRPr sz="2000"/>
+            <a:lvl6pPr marL="2284628" indent="0">
+              <a:buNone/>
+              <a:defRPr sz="1999"/>
             </a:lvl6pPr>
-            <a:lvl7pPr marL="2743200" indent="0">
-              <a:buNone/>
-              <a:defRPr sz="2000"/>
+            <a:lvl7pPr marL="2741554" indent="0">
+              <a:buNone/>
+              <a:defRPr sz="1999"/>
             </a:lvl7pPr>
-            <a:lvl8pPr marL="3200400" indent="0">
-              <a:buNone/>
-              <a:defRPr sz="2000"/>
+            <a:lvl8pPr marL="3198480" indent="0">
+              <a:buNone/>
+              <a:defRPr sz="1999"/>
             </a:lvl8pPr>
-            <a:lvl9pPr marL="3657600" indent="0">
-              <a:buNone/>
-              <a:defRPr sz="2000"/>
+            <a:lvl9pPr marL="3655405" indent="0">
+              <a:buNone/>
+              <a:defRPr sz="1999"/>
             </a:lvl9pPr>
           </a:lstStyle>
           <a:p>
@@ -2434,8 +2434,8 @@
         </p:nvSpPr>
         <p:spPr>
           <a:xfrm>
-            <a:off x="1792288" y="5367338"/>
-            <a:ext cx="5486400" cy="804862"/>
+            <a:off x="1791159" y="5367338"/>
+            <a:ext cx="5482945" cy="804862"/>
           </a:xfrm>
         </p:spPr>
         <p:txBody>
@@ -2443,39 +2443,39 @@
           <a:lstStyle>
             <a:lvl1pPr marL="0" indent="0">
               <a:buNone/>
-              <a:defRPr sz="1400"/>
+              <a:defRPr sz="1399"/>
             </a:lvl1pPr>
-            <a:lvl2pPr marL="457200" indent="0">
-              <a:buNone/>
-              <a:defRPr sz="1200"/>
+            <a:lvl2pPr marL="456926" indent="0">
+              <a:buNone/>
+              <a:defRPr sz="1199"/>
             </a:lvl2pPr>
-            <a:lvl3pPr marL="914400" indent="0">
-              <a:buNone/>
-              <a:defRPr sz="1000"/>
+            <a:lvl3pPr marL="913851" indent="0">
+              <a:buNone/>
+              <a:defRPr sz="999"/>
             </a:lvl3pPr>
-            <a:lvl4pPr marL="1371600" indent="0">
-              <a:buNone/>
-              <a:defRPr sz="900"/>
+            <a:lvl4pPr marL="1370777" indent="0">
+              <a:buNone/>
+              <a:defRPr sz="899"/>
             </a:lvl4pPr>
-            <a:lvl5pPr marL="1828800" indent="0">
-              <a:buNone/>
-              <a:defRPr sz="900"/>
+            <a:lvl5pPr marL="1827703" indent="0">
+              <a:buNone/>
+              <a:defRPr sz="899"/>
             </a:lvl5pPr>
-            <a:lvl6pPr marL="2286000" indent="0">
-              <a:buNone/>
-              <a:defRPr sz="900"/>
+            <a:lvl6pPr marL="2284628" indent="0">
+              <a:buNone/>
+              <a:defRPr sz="899"/>
             </a:lvl6pPr>
-            <a:lvl7pPr marL="2743200" indent="0">
-              <a:buNone/>
-              <a:defRPr sz="900"/>
+            <a:lvl7pPr marL="2741554" indent="0">
+              <a:buNone/>
+              <a:defRPr sz="899"/>
             </a:lvl7pPr>
-            <a:lvl8pPr marL="3200400" indent="0">
-              <a:buNone/>
-              <a:defRPr sz="900"/>
+            <a:lvl8pPr marL="3198480" indent="0">
+              <a:buNone/>
+              <a:defRPr sz="899"/>
             </a:lvl8pPr>
-            <a:lvl9pPr marL="3657600" indent="0">
-              <a:buNone/>
-              <a:defRPr sz="900"/>
+            <a:lvl9pPr marL="3655405" indent="0">
+              <a:buNone/>
+              <a:defRPr sz="899"/>
             </a:lvl9pPr>
           </a:lstStyle>
           <a:p>
@@ -2504,7 +2504,7 @@
           <a:p>
             <a:fld id="{5BCAD085-E8A6-8845-BD4E-CB4CCA059FC4}" type="datetimeFigureOut">
               <a:rPr lang="en-US" smtClean="0"/>
-              <a:t>7/9/2026</a:t>
+              <a:t>7/11/2026</a:t>
             </a:fld>
             <a:endParaRPr lang="en-US"/>
           </a:p>
@@ -2599,8 +2599,8 @@
         </p:nvSpPr>
         <p:spPr>
           <a:xfrm>
-            <a:off x="457200" y="274638"/>
-            <a:ext cx="8229600" cy="1143000"/>
+            <a:off x="456912" y="274638"/>
+            <a:ext cx="8224417" cy="1143000"/>
           </a:xfrm>
           <a:prstGeom prst="rect">
             <a:avLst/>
@@ -2631,8 +2631,8 @@
         </p:nvSpPr>
         <p:spPr>
           <a:xfrm>
-            <a:off x="457200" y="1600200"/>
-            <a:ext cx="8229600" cy="4525963"/>
+            <a:off x="456912" y="1600201"/>
+            <a:ext cx="8224417" cy="4525963"/>
           </a:xfrm>
           <a:prstGeom prst="rect">
             <a:avLst/>
@@ -2692,8 +2692,8 @@
         </p:nvSpPr>
         <p:spPr>
           <a:xfrm>
-            <a:off x="457200" y="6356350"/>
-            <a:ext cx="2133600" cy="365125"/>
+            <a:off x="456912" y="6356350"/>
+            <a:ext cx="2132256" cy="365125"/>
           </a:xfrm>
           <a:prstGeom prst="rect">
             <a:avLst/>
@@ -2703,7 +2703,7 @@
           <a:bodyPr vert="horz" lIns="91440" tIns="45720" rIns="91440" bIns="45720" rtlCol="0" anchor="ctr"/>
           <a:lstStyle>
             <a:lvl1pPr algn="l">
-              <a:defRPr sz="1200">
+              <a:defRPr sz="1199">
                 <a:solidFill>
                   <a:schemeClr val="tx1">
                     <a:tint val="75000"/>
@@ -2715,7 +2715,7 @@
           <a:p>
             <a:fld id="{5BCAD085-E8A6-8845-BD4E-CB4CCA059FC4}" type="datetimeFigureOut">
               <a:rPr lang="en-US" smtClean="0"/>
-              <a:t>7/9/2026</a:t>
+              <a:t>7/11/2026</a:t>
             </a:fld>
             <a:endParaRPr lang="en-US"/>
           </a:p>
@@ -2733,8 +2733,8 @@
         </p:nvSpPr>
         <p:spPr>
           <a:xfrm>
-            <a:off x="3124200" y="6356350"/>
-            <a:ext cx="2895600" cy="365125"/>
+            <a:off x="3122233" y="6356350"/>
+            <a:ext cx="2893776" cy="365125"/>
           </a:xfrm>
           <a:prstGeom prst="rect">
             <a:avLst/>
@@ -2744,7 +2744,7 @@
           <a:bodyPr vert="horz" lIns="91440" tIns="45720" rIns="91440" bIns="45720" rtlCol="0" anchor="ctr"/>
           <a:lstStyle>
             <a:lvl1pPr algn="ctr">
-              <a:defRPr sz="1200">
+              <a:defRPr sz="1199">
                 <a:solidFill>
                   <a:schemeClr val="tx1">
                     <a:tint val="75000"/>
@@ -2770,8 +2770,8 @@
         </p:nvSpPr>
         <p:spPr>
           <a:xfrm>
-            <a:off x="6553200" y="6356350"/>
-            <a:ext cx="2133600" cy="365125"/>
+            <a:off x="6549073" y="6356350"/>
+            <a:ext cx="2132256" cy="365125"/>
           </a:xfrm>
           <a:prstGeom prst="rect">
             <a:avLst/>
@@ -2781,7 +2781,7 @@
           <a:bodyPr vert="horz" lIns="91440" tIns="45720" rIns="91440" bIns="45720" rtlCol="0" anchor="ctr"/>
           <a:lstStyle>
             <a:lvl1pPr algn="r">
-              <a:defRPr sz="1200">
+              <a:defRPr sz="1199">
                 <a:solidFill>
                   <a:schemeClr val="tx1">
                     <a:tint val="75000"/>
@@ -2822,12 +2822,12 @@
   </p:sldLayoutIdLst>
   <p:txStyles>
     <p:titleStyle>
-      <a:lvl1pPr algn="ctr" defTabSz="457200" rtl="0" eaLnBrk="1" latinLnBrk="0" hangingPunct="1">
+      <a:lvl1pPr algn="ctr" defTabSz="456926" rtl="0" eaLnBrk="1" latinLnBrk="0" hangingPunct="1">
         <a:spcBef>
           <a:spcPct val="0"/>
         </a:spcBef>
         <a:buNone/>
-        <a:defRPr sz="4400" kern="1200">
+        <a:defRPr sz="4397" kern="1200">
           <a:solidFill>
             <a:schemeClr val="tx1"/>
           </a:solidFill>
@@ -2838,13 +2838,13 @@
       </a:lvl1pPr>
     </p:titleStyle>
     <p:bodyStyle>
-      <a:lvl1pPr marL="342900" indent="-342900" algn="l" defTabSz="457200" rtl="0" eaLnBrk="1" latinLnBrk="0" hangingPunct="1">
+      <a:lvl1pPr marL="342694" indent="-342694" algn="l" defTabSz="456926" rtl="0" eaLnBrk="1" latinLnBrk="0" hangingPunct="1">
         <a:spcBef>
           <a:spcPct val="20000"/>
         </a:spcBef>
         <a:buFont typeface="Arial"/>
         <a:buChar char="•"/>
-        <a:defRPr sz="3200" kern="1200">
+        <a:defRPr sz="3198" kern="1200">
           <a:solidFill>
             <a:schemeClr val="tx1"/>
           </a:solidFill>
@@ -2853,13 +2853,13 @@
           <a:cs typeface="+mn-cs"/>
         </a:defRPr>
       </a:lvl1pPr>
-      <a:lvl2pPr marL="742950" indent="-285750" algn="l" defTabSz="457200" rtl="0" eaLnBrk="1" latinLnBrk="0" hangingPunct="1">
+      <a:lvl2pPr marL="742504" indent="-285579" algn="l" defTabSz="456926" rtl="0" eaLnBrk="1" latinLnBrk="0" hangingPunct="1">
         <a:spcBef>
           <a:spcPct val="20000"/>
         </a:spcBef>
         <a:buFont typeface="Arial"/>
         <a:buChar char="–"/>
-        <a:defRPr sz="2800" kern="1200">
+        <a:defRPr sz="2798" kern="1200">
           <a:solidFill>
             <a:schemeClr val="tx1"/>
           </a:solidFill>
@@ -2868,13 +2868,13 @@
           <a:cs typeface="+mn-cs"/>
         </a:defRPr>
       </a:lvl2pPr>
-      <a:lvl3pPr marL="1143000" indent="-228600" algn="l" defTabSz="457200" rtl="0" eaLnBrk="1" latinLnBrk="0" hangingPunct="1">
+      <a:lvl3pPr marL="1142314" indent="-228463" algn="l" defTabSz="456926" rtl="0" eaLnBrk="1" latinLnBrk="0" hangingPunct="1">
         <a:spcBef>
           <a:spcPct val="20000"/>
         </a:spcBef>
         <a:buFont typeface="Arial"/>
         <a:buChar char="•"/>
-        <a:defRPr sz="2400" kern="1200">
+        <a:defRPr sz="2399" kern="1200">
           <a:solidFill>
             <a:schemeClr val="tx1"/>
           </a:solidFill>
@@ -2883,13 +2883,13 @@
           <a:cs typeface="+mn-cs"/>
         </a:defRPr>
       </a:lvl3pPr>
-      <a:lvl4pPr marL="1600200" indent="-228600" algn="l" defTabSz="457200" rtl="0" eaLnBrk="1" latinLnBrk="0" hangingPunct="1">
+      <a:lvl4pPr marL="1599240" indent="-228463" algn="l" defTabSz="456926" rtl="0" eaLnBrk="1" latinLnBrk="0" hangingPunct="1">
         <a:spcBef>
           <a:spcPct val="20000"/>
         </a:spcBef>
         <a:buFont typeface="Arial"/>
         <a:buChar char="–"/>
-        <a:defRPr sz="2000" kern="1200">
+        <a:defRPr sz="1999" kern="1200">
           <a:solidFill>
             <a:schemeClr val="tx1"/>
           </a:solidFill>
@@ -2898,13 +2898,13 @@
           <a:cs typeface="+mn-cs"/>
         </a:defRPr>
       </a:lvl4pPr>
-      <a:lvl5pPr marL="2057400" indent="-228600" algn="l" defTabSz="457200" rtl="0" eaLnBrk="1" latinLnBrk="0" hangingPunct="1">
+      <a:lvl5pPr marL="2056166" indent="-228463" algn="l" defTabSz="456926" rtl="0" eaLnBrk="1" latinLnBrk="0" hangingPunct="1">
         <a:spcBef>
           <a:spcPct val="20000"/>
         </a:spcBef>
         <a:buFont typeface="Arial"/>
         <a:buChar char="»"/>
-        <a:defRPr sz="2000" kern="1200">
+        <a:defRPr sz="1999" kern="1200">
           <a:solidFill>
             <a:schemeClr val="tx1"/>
           </a:solidFill>
@@ -2913,13 +2913,13 @@
           <a:cs typeface="+mn-cs"/>
         </a:defRPr>
       </a:lvl5pPr>
-      <a:lvl6pPr marL="2514600" indent="-228600" algn="l" defTabSz="457200" rtl="0" eaLnBrk="1" latinLnBrk="0" hangingPunct="1">
+      <a:lvl6pPr marL="2513091" indent="-228463" algn="l" defTabSz="456926" rtl="0" eaLnBrk="1" latinLnBrk="0" hangingPunct="1">
         <a:spcBef>
           <a:spcPct val="20000"/>
         </a:spcBef>
         <a:buFont typeface="Arial"/>
         <a:buChar char="•"/>
-        <a:defRPr sz="2000" kern="1200">
+        <a:defRPr sz="1999" kern="1200">
           <a:solidFill>
             <a:schemeClr val="tx1"/>
           </a:solidFill>
@@ -2928,13 +2928,13 @@
           <a:cs typeface="+mn-cs"/>
         </a:defRPr>
       </a:lvl6pPr>
-      <a:lvl7pPr marL="2971800" indent="-228600" algn="l" defTabSz="457200" rtl="0" eaLnBrk="1" latinLnBrk="0" hangingPunct="1">
+      <a:lvl7pPr marL="2970017" indent="-228463" algn="l" defTabSz="456926" rtl="0" eaLnBrk="1" latinLnBrk="0" hangingPunct="1">
         <a:spcBef>
           <a:spcPct val="20000"/>
         </a:spcBef>
         <a:buFont typeface="Arial"/>
         <a:buChar char="•"/>
-        <a:defRPr sz="2000" kern="1200">
+        <a:defRPr sz="1999" kern="1200">
           <a:solidFill>
             <a:schemeClr val="tx1"/>
           </a:solidFill>
@@ -2943,13 +2943,13 @@
           <a:cs typeface="+mn-cs"/>
         </a:defRPr>
       </a:lvl7pPr>
-      <a:lvl8pPr marL="3429000" indent="-228600" algn="l" defTabSz="457200" rtl="0" eaLnBrk="1" latinLnBrk="0" hangingPunct="1">
+      <a:lvl8pPr marL="3426943" indent="-228463" algn="l" defTabSz="456926" rtl="0" eaLnBrk="1" latinLnBrk="0" hangingPunct="1">
         <a:spcBef>
           <a:spcPct val="20000"/>
         </a:spcBef>
         <a:buFont typeface="Arial"/>
         <a:buChar char="•"/>
-        <a:defRPr sz="2000" kern="1200">
+        <a:defRPr sz="1999" kern="1200">
           <a:solidFill>
             <a:schemeClr val="tx1"/>
           </a:solidFill>
@@ -2958,13 +2958,13 @@
           <a:cs typeface="+mn-cs"/>
         </a:defRPr>
       </a:lvl8pPr>
-      <a:lvl9pPr marL="3886200" indent="-228600" algn="l" defTabSz="457200" rtl="0" eaLnBrk="1" latinLnBrk="0" hangingPunct="1">
+      <a:lvl9pPr marL="3883868" indent="-228463" algn="l" defTabSz="456926" rtl="0" eaLnBrk="1" latinLnBrk="0" hangingPunct="1">
         <a:spcBef>
           <a:spcPct val="20000"/>
         </a:spcBef>
         <a:buFont typeface="Arial"/>
         <a:buChar char="•"/>
-        <a:defRPr sz="2000" kern="1200">
+        <a:defRPr sz="1999" kern="1200">
           <a:solidFill>
             <a:schemeClr val="tx1"/>
           </a:solidFill>
@@ -2978,8 +2978,8 @@
       <a:defPPr>
         <a:defRPr lang="en-US"/>
       </a:defPPr>
-      <a:lvl1pPr marL="0" algn="l" defTabSz="457200" rtl="0" eaLnBrk="1" latinLnBrk="0" hangingPunct="1">
-        <a:defRPr sz="1800" kern="1200">
+      <a:lvl1pPr marL="0" algn="l" defTabSz="456926" rtl="0" eaLnBrk="1" latinLnBrk="0" hangingPunct="1">
+        <a:defRPr sz="1799" kern="1200">
           <a:solidFill>
             <a:schemeClr val="tx1"/>
           </a:solidFill>
@@ -2988,8 +2988,8 @@
           <a:cs typeface="+mn-cs"/>
         </a:defRPr>
       </a:lvl1pPr>
-      <a:lvl2pPr marL="457200" algn="l" defTabSz="457200" rtl="0" eaLnBrk="1" latinLnBrk="0" hangingPunct="1">
-        <a:defRPr sz="1800" kern="1200">
+      <a:lvl2pPr marL="456926" algn="l" defTabSz="456926" rtl="0" eaLnBrk="1" latinLnBrk="0" hangingPunct="1">
+        <a:defRPr sz="1799" kern="1200">
           <a:solidFill>
             <a:schemeClr val="tx1"/>
           </a:solidFill>
@@ -2998,8 +2998,8 @@
           <a:cs typeface="+mn-cs"/>
         </a:defRPr>
       </a:lvl2pPr>
-      <a:lvl3pPr marL="914400" algn="l" defTabSz="457200" rtl="0" eaLnBrk="1" latinLnBrk="0" hangingPunct="1">
-        <a:defRPr sz="1800" kern="1200">
+      <a:lvl3pPr marL="913851" algn="l" defTabSz="456926" rtl="0" eaLnBrk="1" latinLnBrk="0" hangingPunct="1">
+        <a:defRPr sz="1799" kern="1200">
           <a:solidFill>
             <a:schemeClr val="tx1"/>
           </a:solidFill>
@@ -3008,8 +3008,8 @@
           <a:cs typeface="+mn-cs"/>
         </a:defRPr>
       </a:lvl3pPr>
-      <a:lvl4pPr marL="1371600" algn="l" defTabSz="457200" rtl="0" eaLnBrk="1" latinLnBrk="0" hangingPunct="1">
-        <a:defRPr sz="1800" kern="1200">
+      <a:lvl4pPr marL="1370777" algn="l" defTabSz="456926" rtl="0" eaLnBrk="1" latinLnBrk="0" hangingPunct="1">
+        <a:defRPr sz="1799" kern="1200">
           <a:solidFill>
             <a:schemeClr val="tx1"/>
           </a:solidFill>
@@ -3018,8 +3018,8 @@
           <a:cs typeface="+mn-cs"/>
         </a:defRPr>
       </a:lvl4pPr>
-      <a:lvl5pPr marL="1828800" algn="l" defTabSz="457200" rtl="0" eaLnBrk="1" latinLnBrk="0" hangingPunct="1">
-        <a:defRPr sz="1800" kern="1200">
+      <a:lvl5pPr marL="1827703" algn="l" defTabSz="456926" rtl="0" eaLnBrk="1" latinLnBrk="0" hangingPunct="1">
+        <a:defRPr sz="1799" kern="1200">
           <a:solidFill>
             <a:schemeClr val="tx1"/>
           </a:solidFill>
@@ -3028,8 +3028,8 @@
           <a:cs typeface="+mn-cs"/>
         </a:defRPr>
       </a:lvl5pPr>
-      <a:lvl6pPr marL="2286000" algn="l" defTabSz="457200" rtl="0" eaLnBrk="1" latinLnBrk="0" hangingPunct="1">
-        <a:defRPr sz="1800" kern="1200">
+      <a:lvl6pPr marL="2284628" algn="l" defTabSz="456926" rtl="0" eaLnBrk="1" latinLnBrk="0" hangingPunct="1">
+        <a:defRPr sz="1799" kern="1200">
           <a:solidFill>
             <a:schemeClr val="tx1"/>
           </a:solidFill>
@@ -3038,8 +3038,8 @@
           <a:cs typeface="+mn-cs"/>
         </a:defRPr>
       </a:lvl6pPr>
-      <a:lvl7pPr marL="2743200" algn="l" defTabSz="457200" rtl="0" eaLnBrk="1" latinLnBrk="0" hangingPunct="1">
-        <a:defRPr sz="1800" kern="1200">
+      <a:lvl7pPr marL="2741554" algn="l" defTabSz="456926" rtl="0" eaLnBrk="1" latinLnBrk="0" hangingPunct="1">
+        <a:defRPr sz="1799" kern="1200">
           <a:solidFill>
             <a:schemeClr val="tx1"/>
           </a:solidFill>
@@ -3048,8 +3048,8 @@
           <a:cs typeface="+mn-cs"/>
         </a:defRPr>
       </a:lvl7pPr>
-      <a:lvl8pPr marL="3200400" algn="l" defTabSz="457200" rtl="0" eaLnBrk="1" latinLnBrk="0" hangingPunct="1">
-        <a:defRPr sz="1800" kern="1200">
+      <a:lvl8pPr marL="3198480" algn="l" defTabSz="456926" rtl="0" eaLnBrk="1" latinLnBrk="0" hangingPunct="1">
+        <a:defRPr sz="1799" kern="1200">
           <a:solidFill>
             <a:schemeClr val="tx1"/>
           </a:solidFill>
@@ -3058,8 +3058,8 @@
           <a:cs typeface="+mn-cs"/>
         </a:defRPr>
       </a:lvl8pPr>
-      <a:lvl9pPr marL="3657600" algn="l" defTabSz="457200" rtl="0" eaLnBrk="1" latinLnBrk="0" hangingPunct="1">
-        <a:defRPr sz="1800" kern="1200">
+      <a:lvl9pPr marL="3655405" algn="l" defTabSz="456926" rtl="0" eaLnBrk="1" latinLnBrk="0" hangingPunct="1">
+        <a:defRPr sz="1799" kern="1200">
           <a:solidFill>
             <a:schemeClr val="tx1"/>
           </a:solidFill>
@@ -3106,8 +3106,8 @@
         </p:blipFill>
         <p:spPr>
           <a:xfrm>
-            <a:off x="53633" y="15412"/>
-            <a:ext cx="15033580" cy="10637722"/>
+            <a:off x="53600" y="18768"/>
+            <a:ext cx="15024112" cy="10631022"/>
           </a:xfrm>
           <a:prstGeom prst="rect">
             <a:avLst/>
@@ -3122,8 +3122,8 @@
         </p:nvSpPr>
         <p:spPr>
           <a:xfrm>
-            <a:off x="1170443" y="145756"/>
-            <a:ext cx="13774282" cy="448473"/>
+            <a:off x="1169706" y="149030"/>
+            <a:ext cx="13765607" cy="448191"/>
           </a:xfrm>
           <a:prstGeom prst="rect">
             <a:avLst/>
@@ -3171,7 +3171,7 @@
           </a:sp3d>
         </p:spPr>
         <p:txBody>
-          <a:bodyPr wrap="square" lIns="169815" tIns="84908" rIns="169815" bIns="84908">
+          <a:bodyPr wrap="square" lIns="169708" tIns="84855" rIns="169708" bIns="84855">
             <a:spAutoFit/>
           </a:bodyPr>
           <a:lstStyle>
@@ -3245,11 +3245,11 @@
             </a:lvl9pPr>
           </a:lstStyle>
           <a:p>
-            <a:pPr defTabSz="1474788" eaLnBrk="1" hangingPunct="1">
+            <a:pPr defTabSz="1473903">
               <a:defRPr/>
             </a:pPr>
             <a:r>
-              <a:rPr lang="en-US" sz="1800" kern="0">
+              <a:rPr lang="en-US" sz="1799" kern="0">
                 <a:solidFill>
                   <a:prstClr val="black"/>
                 </a:solidFill>
@@ -3258,7 +3258,7 @@
               </a:rPr>
               <a:t>NAME</a:t>
             </a:r>
-            <a:endParaRPr lang="vi-VN" sz="1800" kern="0" dirty="0">
+            <a:endParaRPr lang="vi-VN" sz="1799" kern="0" dirty="0">
               <a:solidFill>
                 <a:prstClr val="black"/>
               </a:solidFill>
@@ -3278,8 +3278,8 @@
         </p:nvSpPr>
         <p:spPr bwMode="auto">
           <a:xfrm>
-            <a:off x="8148501" y="926591"/>
-            <a:ext cx="1352961" cy="295607"/>
+            <a:off x="8143370" y="929374"/>
+            <a:ext cx="1352109" cy="295421"/>
           </a:xfrm>
           <a:prstGeom prst="rect">
             <a:avLst/>
@@ -3304,14 +3304,14 @@
           </a:extLst>
         </p:spPr>
         <p:txBody>
-          <a:bodyPr wrap="none" lIns="79388" tIns="39694" rIns="79388" bIns="39694">
+          <a:bodyPr wrap="none" lIns="79338" tIns="39669" rIns="79338" bIns="39669">
             <a:spAutoFit/>
           </a:bodyPr>
           <a:lstStyle/>
           <a:p>
             <a:pPr algn="ctr"/>
             <a:r>
-              <a:rPr lang="en-US" altLang="en-US" sz="1400" b="1" dirty="0">
+              <a:rPr lang="en-US" altLang="en-US" sz="1399" b="1" dirty="0">
                 <a:solidFill>
                   <a:srgbClr val="FFFF00"/>
                 </a:solidFill>
@@ -3319,7 +3319,7 @@
               </a:rPr>
               <a:t>10.25/07.07.26</a:t>
             </a:r>
-            <a:endParaRPr lang="vi-VN" altLang="en-US" sz="1400" b="1" dirty="0">
+            <a:endParaRPr lang="vi-VN" altLang="en-US" sz="1399" b="1" dirty="0">
               <a:solidFill>
                 <a:srgbClr val="FFFF00"/>
               </a:solidFill>
@@ -3351,8 +3351,8 @@
         </p:blipFill>
         <p:spPr bwMode="auto">
           <a:xfrm>
-            <a:off x="14199227" y="1081812"/>
-            <a:ext cx="327025" cy="819150"/>
+            <a:off x="14190286" y="1084497"/>
+            <a:ext cx="326819" cy="818634"/>
           </a:xfrm>
           <a:prstGeom prst="rect">
             <a:avLst/>
@@ -3402,8 +3402,8 @@
         </p:nvSpPr>
         <p:spPr bwMode="auto">
           <a:xfrm>
-            <a:off x="1415236" y="946677"/>
-            <a:ext cx="1352961" cy="295607"/>
+            <a:off x="1414346" y="949447"/>
+            <a:ext cx="1352109" cy="295421"/>
           </a:xfrm>
           <a:prstGeom prst="rect">
             <a:avLst/>
@@ -3428,14 +3428,14 @@
           </a:extLst>
         </p:spPr>
         <p:txBody>
-          <a:bodyPr wrap="none" lIns="79388" tIns="39694" rIns="79388" bIns="39694">
+          <a:bodyPr wrap="none" lIns="79338" tIns="39669" rIns="79338" bIns="39669">
             <a:spAutoFit/>
           </a:bodyPr>
           <a:lstStyle/>
           <a:p>
             <a:pPr algn="ctr"/>
             <a:r>
-              <a:rPr lang="en-US" altLang="en-US" sz="1400" b="1" dirty="0">
+              <a:rPr lang="en-US" altLang="en-US" sz="1399" b="1" dirty="0">
                 <a:solidFill>
                   <a:srgbClr val="FFFF00"/>
                 </a:solidFill>
@@ -3443,7 +3443,7 @@
               </a:rPr>
               <a:t>09.51/06.07.26</a:t>
             </a:r>
-            <a:endParaRPr lang="vi-VN" altLang="en-US" sz="1400" b="1" dirty="0">
+            <a:endParaRPr lang="vi-VN" altLang="en-US" sz="1399" b="1" dirty="0">
               <a:solidFill>
                 <a:srgbClr val="FFFF00"/>
               </a:solidFill>
@@ -3475,8 +3475,8 @@
         </p:blipFill>
         <p:spPr bwMode="auto">
           <a:xfrm>
-            <a:off x="7570447" y="1069112"/>
-            <a:ext cx="327025" cy="819150"/>
+            <a:off x="7565680" y="1071805"/>
+            <a:ext cx="326819" cy="818634"/>
           </a:xfrm>
           <a:prstGeom prst="rect">
             <a:avLst/>
@@ -3526,8 +3526,8 @@
         </p:nvSpPr>
         <p:spPr bwMode="auto">
           <a:xfrm>
-            <a:off x="9976928" y="9810583"/>
-            <a:ext cx="2875472" cy="295607"/>
+            <a:off x="9970645" y="9807771"/>
+            <a:ext cx="2873661" cy="295421"/>
           </a:xfrm>
           <a:prstGeom prst="rect">
             <a:avLst/>
@@ -3552,7 +3552,7 @@
           </a:extLst>
         </p:spPr>
         <p:txBody>
-          <a:bodyPr wrap="square" lIns="79388" tIns="39694" rIns="79388" bIns="39694">
+          <a:bodyPr wrap="square" lIns="79338" tIns="39669" rIns="79338" bIns="39669">
             <a:spAutoFit/>
           </a:bodyPr>
           <a:lstStyle>
@@ -3656,7 +3656,7 @@
           <a:p>
             <a:pPr algn="ctr" eaLnBrk="1" hangingPunct="1"/>
             <a:r>
-              <a:rPr lang="en-US" altLang="en-US" sz="1400" b="1" dirty="0" err="1">
+              <a:rPr lang="en-US" altLang="en-US" sz="1399" b="1" dirty="0" err="1">
                 <a:solidFill>
                   <a:srgbClr val="FFFF00"/>
                 </a:solidFill>
@@ -3665,7 +3665,7 @@
               </a:rPr>
               <a:t>Không phát hiện tàu quân sự</a:t>
             </a:r>
-            <a:endParaRPr lang="en-US" altLang="en-US" sz="1400" b="1" dirty="0">
+            <a:endParaRPr lang="en-US" altLang="en-US" sz="1399" b="1" dirty="0">
               <a:solidFill>
                 <a:srgbClr val="FFFF00"/>
               </a:solidFill>
@@ -3685,8 +3685,8 @@
         </p:nvSpPr>
         <p:spPr bwMode="auto">
           <a:xfrm>
-            <a:off x="3728693" y="9810584"/>
-            <a:ext cx="2257441" cy="295607"/>
+            <a:off x="3726346" y="9807772"/>
+            <a:ext cx="2256019" cy="295421"/>
           </a:xfrm>
           <a:prstGeom prst="rect">
             <a:avLst/>
@@ -3711,7 +3711,7 @@
           </a:extLst>
         </p:spPr>
         <p:txBody>
-          <a:bodyPr wrap="square" lIns="79388" tIns="39694" rIns="79388" bIns="39694">
+          <a:bodyPr wrap="square" lIns="79338" tIns="39669" rIns="79338" bIns="39669">
             <a:spAutoFit/>
           </a:bodyPr>
           <a:lstStyle>
@@ -3815,7 +3815,7 @@
           <a:p>
             <a:pPr algn="ctr" eaLnBrk="1" hangingPunct="1"/>
             <a:r>
-              <a:rPr lang="en-US" altLang="en-US" sz="1400" b="1" dirty="0" err="1">
+              <a:rPr lang="en-US" altLang="en-US" sz="1399" b="1" dirty="0" err="1">
                 <a:solidFill>
                   <a:srgbClr val="FFFF00"/>
                 </a:solidFill>
@@ -3835,8 +3835,8 @@
         </p:nvSpPr>
         <p:spPr>
           <a:xfrm>
-            <a:off x="1954793" y="7119742"/>
-            <a:ext cx="3167886" cy="307777"/>
+            <a:off x="1953562" y="7118624"/>
+            <a:ext cx="3165891" cy="307583"/>
           </a:xfrm>
           <a:prstGeom prst="rect">
             <a:avLst/>
@@ -3879,20 +3879,14 @@
             </a:lvl1pPr>
           </a:lstStyle>
           <a:p>
-            <a:pPr defTabSz="1475000" eaLnBrk="1" fontAlgn="auto" hangingPunct="1">
-              <a:spcBef>
-                <a:spcPts val="0"/>
-              </a:spcBef>
-              <a:spcAft>
-                <a:spcPts val="0"/>
-              </a:spcAft>
+            <a:pPr defTabSz="1474115">
               <a:defRPr/>
             </a:pPr>
             <a:r>
-              <a:rPr lang="en-US" sz="1400"/>
+              <a:rPr lang="en-US" sz="1399"/>
               <a:t>xxx</a:t>
             </a:r>
-            <a:endParaRPr lang="en-US" sz="1400" dirty="0"/>
+            <a:endParaRPr lang="en-US" sz="1399" dirty="0"/>
           </a:p>
         </p:txBody>
       </p:sp>
@@ -3904,8 +3898,8 @@
         </p:nvCxnSpPr>
         <p:spPr>
           <a:xfrm flipV="1">
-            <a:off x="3272437" y="6786817"/>
-            <a:ext cx="732975" cy="185274"/>
+            <a:off x="3270377" y="6785909"/>
+            <a:ext cx="732513" cy="185157"/>
           </a:xfrm>
           <a:prstGeom prst="straightConnector1">
             <a:avLst/>
@@ -3941,8 +3935,8 @@
         </p:nvCxnSpPr>
         <p:spPr>
           <a:xfrm flipH="1" flipV="1">
-            <a:off x="3172871" y="5965839"/>
-            <a:ext cx="99567" cy="1006251"/>
+            <a:off x="3170874" y="5965448"/>
+            <a:ext cx="99504" cy="1005617"/>
           </a:xfrm>
           <a:prstGeom prst="straightConnector1">
             <a:avLst/>

</xml_diff>